<commit_message>
align slides with overview: remove setup slide, update goals
- Remove Slide 15 (始め方) — setup instructions not needed
- Update Slide 02: session 2/3 keywords and content
  - 第2回: プロジェクトに合わせたカスタマイズ (CLAUDE.md/Skills/Hooks)
  - 第3回: 外部連携と並列開発 (MCP/worktree/サブエージェント)
- Update goal to 日常業務の一部をClaude Codeに任せられるようになる
- Update summary CTA and speaker notes to match
- Total: 16 → 15 slides

https://claude.ai/code/session_01HsuWpdQiipBM1Ba8gR5uW7
</commit_message>
<xml_diff>
--- a/slides/session1.pptx
+++ b/slides/session1.pptx
@@ -20,7 +20,6 @@
     <p:sldId id="268" r:id="rId20"/>
     <p:sldId id="269" r:id="rId21"/>
     <p:sldId id="270" r:id="rId22"/>
-    <p:sldId id="271" r:id="rId23"/>
   </p:sldIdLst>
   <p:sldSz cx="12191695" cy="6858000" type="screen4x3"/>
   <p:notesSz cx="6858000" cy="9144000"/>
@@ -1092,101 +1091,6 @@
           <a:lstStyle/>
           <a:p>
             <a:r>
-              <a:t>実際に使い始める手順。</a:t>
-            </a:r>
-          </a:p>
-          <a:p>
-            <a:r>
-              <a:t>インストールはワンライナー。自動更新されるので常に最新版。</a:t>
-            </a:r>
-          </a:p>
-          <a:p>
-            <a:r>
-              <a:t>対象リポジトリのディレクトリで claude を実行するだけ。初回は認証設定が求められる。</a:t>
-            </a:r>
-          </a:p>
-          <a:p>
-            <a:r>
-              <a:t>最初のタスクは結果がわかりやすいものが良い。</a:t>
-            </a:r>
-          </a:p>
-          <a:p>
-            <a:r>
-              <a:t>リポジトリの要約、テスト実行、参照箇所の列挙など。</a:t>
-            </a:r>
-          </a:p>
-          <a:p>
-            <a:r>
-              <a:t>権限設定は /config で確認できる。最初はPlan Mode固定で始めると安全。</a:t>
-            </a:r>
-          </a:p>
-        </p:txBody>
-      </p:sp>
-      <p:sp>
-        <p:nvSpPr>
-          <p:cNvPr id="4" name="Slide Number Placeholder 3"/>
-          <p:cNvSpPr>
-            <a:spLocks noGrp="1"/>
-          </p:cNvSpPr>
-          <p:nvPr>
-            <p:ph type="sldNum" idx="5" sz="quarter"/>
-          </p:nvPr>
-        </p:nvSpPr>
-        <p:spPr/>
-      </p:sp>
-    </p:spTree>
-  </p:cSld>
-  <p:clrMapOvr>
-    <a:masterClrMapping/>
-  </p:clrMapOvr>
-</p:notes>
-</file>
-
-<file path=ppt/notesSlides/notesSlide16.xml><?xml version="1.0" encoding="utf-8"?>
-<p:notes xmlns:a="http://schemas.openxmlformats.org/drawingml/2006/main" xmlns:p="http://schemas.openxmlformats.org/presentationml/2006/main" xmlns:r="http://schemas.openxmlformats.org/officeDocument/2006/relationships">
-  <p:cSld>
-    <p:spTree>
-      <p:nvGrpSpPr>
-        <p:cNvPr id="1" name=""/>
-        <p:cNvGrpSpPr/>
-        <p:nvPr/>
-      </p:nvGrpSpPr>
-      <p:grpSpPr>
-        <a:xfrm>
-          <a:off x="0" y="0"/>
-          <a:ext cx="0" cy="0"/>
-          <a:chOff x="0" y="0"/>
-          <a:chExt cx="0" cy="0"/>
-        </a:xfrm>
-      </p:grpSpPr>
-      <p:sp>
-        <p:nvSpPr>
-          <p:cNvPr id="2" name="Slide Image Placeholder 1"/>
-          <p:cNvSpPr>
-            <a:spLocks noGrp="1"/>
-          </p:cNvSpPr>
-          <p:nvPr>
-            <p:ph type="sldImg" idx="2"/>
-          </p:nvPr>
-        </p:nvSpPr>
-        <p:spPr/>
-      </p:sp>
-      <p:sp>
-        <p:nvSpPr>
-          <p:cNvPr id="3" name="Notes Placeholder 2"/>
-          <p:cNvSpPr>
-            <a:spLocks noGrp="1"/>
-          </p:cNvSpPr>
-          <p:nvPr>
-            <p:ph type="body" idx="3" sz="quarter"/>
-          </p:nvPr>
-        </p:nvSpPr>
-        <p:spPr/>
-        <p:txBody>
-          <a:bodyPr/>
-          <a:lstStyle/>
-          <a:p>
-            <a:r>
               <a:t>まとめ。今日の持ち帰りは3つ。</a:t>
             </a:r>
           </a:p>
@@ -1207,12 +1111,12 @@
           </a:p>
           <a:p>
             <a:r>
-              <a:t>面倒な調査タスクを1件、任せてみてほしい。</a:t>
-            </a:r>
-          </a:p>
-          <a:p>
-            <a:r>
-              <a:t>次回は「カスタマイズする」がテーマ。コンテキスト管理、Skills、サブエージェント。</a:t>
+              <a:t>日常業務の一部を、まず任せてみてほしい。</a:t>
+            </a:r>
+          </a:p>
+          <a:p>
+            <a:r>
+              <a:t>次回は「プロジェクトに合わせたカスタマイズ」。CLAUDE.md、Skills、Hooks。</a:t>
             </a:r>
           </a:p>
           <a:p>
@@ -1297,12 +1201,12 @@
           </a:p>
           <a:p>
             <a:r>
-              <a:t>第2回は「カスタマイズする」。チームに合わせた設定。</a:t>
-            </a:r>
-          </a:p>
-          <a:p>
-            <a:r>
-              <a:t>第3回は「スケールさせる」。自動化と並列化。</a:t>
+              <a:t>第2回は「プロジェクトに合わせたカスタマイズ」。CLAUDE.md、Skills、Hooks。</a:t>
+            </a:r>
+          </a:p>
+          <a:p>
+            <a:r>
+              <a:t>第3回は「外部連携と並列開発」。MCP、worktree、サブエージェント。</a:t>
             </a:r>
           </a:p>
           <a:p>
@@ -1312,7 +1216,7 @@
           </a:p>
           <a:p>
             <a:r>
-              <a:t>今日のゴールは明確に。「面倒な調査を1件、任せられる」ようになること。</a:t>
+              <a:t>今日のゴールは「日常業務の一部を任せられる」ようになること。</a:t>
             </a:r>
           </a:p>
         </p:txBody>
@@ -6094,7 +5998,7 @@
               </a:defRPr>
             </a:pPr>
             <a:r>
-              <a:t>10 / 16</a:t>
+              <a:t>10 / 15</a:t>
             </a:r>
           </a:p>
         </p:txBody>
@@ -7077,7 +6981,7 @@
               </a:defRPr>
             </a:pPr>
             <a:r>
-              <a:t>11 / 16</a:t>
+              <a:t>11 / 15</a:t>
             </a:r>
           </a:p>
         </p:txBody>
@@ -7271,7 +7175,7 @@
               </a:defRPr>
             </a:pPr>
             <a:r>
-              <a:t>12 / 16</a:t>
+              <a:t>12 / 15</a:t>
             </a:r>
           </a:p>
         </p:txBody>
@@ -7928,7 +7832,7 @@
               </a:defRPr>
             </a:pPr>
             <a:r>
-              <a:t>13 / 16</a:t>
+              <a:t>13 / 15</a:t>
             </a:r>
           </a:p>
         </p:txBody>
@@ -9361,7 +9265,7 @@
               </a:defRPr>
             </a:pPr>
             <a:r>
-              <a:t>14 / 16</a:t>
+              <a:t>14 / 15</a:t>
             </a:r>
           </a:p>
         </p:txBody>
@@ -9429,437 +9333,21 @@
               </a:defRPr>
             </a:pPr>
             <a:r>
-              <a:t>始め方</a:t>
-            </a:r>
-          </a:p>
-        </p:txBody>
-      </p:sp>
-      <p:sp>
-        <p:nvSpPr>
-          <p:cNvPr id="3" name="TextBox 2"/>
-          <p:cNvSpPr txBox="1"/>
-          <p:nvPr/>
-        </p:nvSpPr>
-        <p:spPr>
-          <a:xfrm>
-            <a:off x="731520" y="1371600"/>
-            <a:ext cx="2743200" cy="457200"/>
-          </a:xfrm>
-          <a:prstGeom prst="rect">
-            <a:avLst/>
-          </a:prstGeom>
-          <a:noFill/>
-        </p:spPr>
-        <p:txBody>
-          <a:bodyPr wrap="square">
-            <a:spAutoFit/>
-          </a:bodyPr>
-          <a:lstStyle/>
-          <a:p>
-            <a:pPr algn="l">
-              <a:lnSpc>
-                <a:spcPts val="3000"/>
-              </a:lnSpc>
-              <a:spcAft>
-                <a:spcPts val="0"/>
-              </a:spcAft>
-              <a:defRPr sz="2000" b="1">
-                <a:solidFill>
-                  <a:srgbClr val="D97757"/>
-                </a:solidFill>
-                <a:latin typeface="Hiragino Sans"/>
-              </a:defRPr>
-            </a:pPr>
-            <a:r>
-              <a:t>インストール</a:t>
-            </a:r>
-          </a:p>
-        </p:txBody>
-      </p:sp>
-      <p:sp>
-        <p:nvSpPr>
-          <p:cNvPr id="4" name="Rounded Rectangle 3"/>
+              <a:t>まとめ / 次回予告</a:t>
+            </a:r>
+          </a:p>
+        </p:txBody>
+      </p:sp>
+      <p:sp>
+        <p:nvSpPr>
+          <p:cNvPr id="3" name="Rounded Rectangle 2"/>
           <p:cNvSpPr/>
           <p:nvPr/>
         </p:nvSpPr>
         <p:spPr>
           <a:xfrm>
-            <a:off x="731520" y="1920240"/>
-            <a:ext cx="5029200" cy="1463040"/>
-          </a:xfrm>
-          <a:prstGeom prst="roundRect">
-            <a:avLst>
-              <a:gd name="adj" fmla="val 3000"/>
-            </a:avLst>
-          </a:prstGeom>
-          <a:solidFill>
-            <a:srgbClr val="141210"/>
-          </a:solidFill>
-          <a:ln>
-            <a:noFill/>
-          </a:ln>
-        </p:spPr>
-        <p:style>
-          <a:lnRef idx="1">
-            <a:schemeClr val="accent1"/>
-          </a:lnRef>
-          <a:fillRef idx="3">
-            <a:schemeClr val="accent1"/>
-          </a:fillRef>
-          <a:effectRef idx="2">
-            <a:schemeClr val="accent1"/>
-          </a:effectRef>
-          <a:fontRef idx="minor">
-            <a:schemeClr val="lt1"/>
-          </a:fontRef>
-        </p:style>
-        <p:txBody>
-          <a:bodyPr rtlCol="0" anchor="ctr"/>
-          <a:lstStyle/>
-          <a:p>
-            <a:pPr algn="ctr"/>
-          </a:p>
-        </p:txBody>
-      </p:sp>
-      <p:sp>
-        <p:nvSpPr>
-          <p:cNvPr id="5" name="TextBox 4"/>
-          <p:cNvSpPr txBox="1"/>
-          <p:nvPr/>
-        </p:nvSpPr>
-        <p:spPr>
-          <a:xfrm>
-            <a:off x="1005840" y="2103120"/>
-            <a:ext cx="4480560" cy="1097280"/>
-          </a:xfrm>
-          <a:prstGeom prst="rect">
-            <a:avLst/>
-          </a:prstGeom>
-          <a:noFill/>
-        </p:spPr>
-        <p:txBody>
-          <a:bodyPr wrap="square">
-            <a:spAutoFit/>
-          </a:bodyPr>
-          <a:lstStyle/>
-          <a:p>
-            <a:pPr>
-              <a:lnSpc>
-                <a:spcPts val="2080"/>
-              </a:lnSpc>
-              <a:spcAft>
-                <a:spcPts val="200"/>
-              </a:spcAft>
-              <a:defRPr sz="1300">
-                <a:solidFill>
-                  <a:srgbClr val="6A9BCC"/>
-                </a:solidFill>
-                <a:latin typeface="SF Mono"/>
-              </a:defRPr>
-            </a:pPr>
-            <a:r>
-              <a:t># Mac</a:t>
-            </a:r>
-          </a:p>
-          <a:p>
-            <a:pPr>
-              <a:lnSpc>
-                <a:spcPts val="2080"/>
-              </a:lnSpc>
-              <a:spcAft>
-                <a:spcPts val="200"/>
-              </a:spcAft>
-              <a:defRPr sz="1300">
-                <a:solidFill>
-                  <a:srgbClr val="6A9BCC"/>
-                </a:solidFill>
-                <a:latin typeface="SF Mono"/>
-              </a:defRPr>
-            </a:pPr>
-            <a:r>
-              <a:t>curl -fsSL https://claude.ai/install.sh | bash</a:t>
-            </a:r>
-          </a:p>
-          <a:p>
-            <a:pPr>
-              <a:lnSpc>
-                <a:spcPts val="2080"/>
-              </a:lnSpc>
-              <a:spcAft>
-                <a:spcPts val="200"/>
-              </a:spcAft>
-              <a:defRPr sz="1300">
-                <a:solidFill>
-                  <a:srgbClr val="6A9BCC"/>
-                </a:solidFill>
-                <a:latin typeface="SF Mono"/>
-              </a:defRPr>
-            </a:pPr>
-          </a:p>
-          <a:p>
-            <a:pPr>
-              <a:lnSpc>
-                <a:spcPts val="2080"/>
-              </a:lnSpc>
-              <a:spcAft>
-                <a:spcPts val="200"/>
-              </a:spcAft>
-              <a:defRPr sz="1300">
-                <a:solidFill>
-                  <a:srgbClr val="6A9BCC"/>
-                </a:solidFill>
-                <a:latin typeface="SF Mono"/>
-              </a:defRPr>
-            </a:pPr>
-            <a:r>
-              <a:t># Windows</a:t>
-            </a:r>
-          </a:p>
-          <a:p>
-            <a:pPr>
-              <a:lnSpc>
-                <a:spcPts val="2080"/>
-              </a:lnSpc>
-              <a:spcAft>
-                <a:spcPts val="200"/>
-              </a:spcAft>
-              <a:defRPr sz="1300">
-                <a:solidFill>
-                  <a:srgbClr val="6A9BCC"/>
-                </a:solidFill>
-                <a:latin typeface="SF Mono"/>
-              </a:defRPr>
-            </a:pPr>
-            <a:r>
-              <a:t>winget install Anthropic.ClaudeCode</a:t>
-            </a:r>
-          </a:p>
-        </p:txBody>
-      </p:sp>
-      <p:sp>
-        <p:nvSpPr>
-          <p:cNvPr id="6" name="TextBox 5"/>
-          <p:cNvSpPr txBox="1"/>
-          <p:nvPr/>
-        </p:nvSpPr>
-        <p:spPr>
-          <a:xfrm>
-            <a:off x="6400800" y="1371600"/>
-            <a:ext cx="4572000" cy="457200"/>
-          </a:xfrm>
-          <a:prstGeom prst="rect">
-            <a:avLst/>
-          </a:prstGeom>
-          <a:noFill/>
-        </p:spPr>
-        <p:txBody>
-          <a:bodyPr wrap="square">
-            <a:spAutoFit/>
-          </a:bodyPr>
-          <a:lstStyle/>
-          <a:p>
-            <a:pPr algn="l">
-              <a:lnSpc>
-                <a:spcPts val="3000"/>
-              </a:lnSpc>
-              <a:spcAft>
-                <a:spcPts val="0"/>
-              </a:spcAft>
-              <a:defRPr sz="2000" b="1">
-                <a:solidFill>
-                  <a:srgbClr val="D97757"/>
-                </a:solidFill>
-                <a:latin typeface="Hiragino Sans"/>
-              </a:defRPr>
-            </a:pPr>
-            <a:r>
-              <a:t>起動</a:t>
-            </a:r>
-          </a:p>
-        </p:txBody>
-      </p:sp>
-      <p:sp>
-        <p:nvSpPr>
-          <p:cNvPr id="7" name="TextBox 6"/>
-          <p:cNvSpPr txBox="1"/>
-          <p:nvPr/>
-        </p:nvSpPr>
-        <p:spPr>
-          <a:xfrm>
-            <a:off x="6400800" y="1920240"/>
-            <a:ext cx="4572000" cy="457200"/>
-          </a:xfrm>
-          <a:prstGeom prst="rect">
-            <a:avLst/>
-          </a:prstGeom>
-          <a:noFill/>
-        </p:spPr>
-        <p:txBody>
-          <a:bodyPr wrap="square">
-            <a:spAutoFit/>
-          </a:bodyPr>
-          <a:lstStyle/>
-          <a:p>
-            <a:pPr algn="l">
-              <a:lnSpc>
-                <a:spcPts val="2400"/>
-              </a:lnSpc>
-              <a:spcAft>
-                <a:spcPts val="0"/>
-              </a:spcAft>
-              <a:defRPr sz="1600" b="0">
-                <a:solidFill>
-                  <a:srgbClr val="C5C3BB"/>
-                </a:solidFill>
-                <a:latin typeface="Hiragino Sans"/>
-              </a:defRPr>
-            </a:pPr>
-            <a:r>
-              <a:t>対象リポジトリで claude を実行</a:t>
-            </a:r>
-          </a:p>
-        </p:txBody>
-      </p:sp>
-      <p:sp>
-        <p:nvSpPr>
-          <p:cNvPr id="8" name="TextBox 7"/>
-          <p:cNvSpPr txBox="1"/>
-          <p:nvPr/>
-        </p:nvSpPr>
-        <p:spPr>
-          <a:xfrm>
-            <a:off x="6400800" y="2651760"/>
-            <a:ext cx="4572000" cy="457200"/>
-          </a:xfrm>
-          <a:prstGeom prst="rect">
-            <a:avLst/>
-          </a:prstGeom>
-          <a:noFill/>
-        </p:spPr>
-        <p:txBody>
-          <a:bodyPr wrap="square">
-            <a:spAutoFit/>
-          </a:bodyPr>
-          <a:lstStyle/>
-          <a:p>
-            <a:pPr algn="l">
-              <a:lnSpc>
-                <a:spcPts val="3000"/>
-              </a:lnSpc>
-              <a:spcAft>
-                <a:spcPts val="0"/>
-              </a:spcAft>
-              <a:defRPr sz="2000" b="1">
-                <a:solidFill>
-                  <a:srgbClr val="D97757"/>
-                </a:solidFill>
-                <a:latin typeface="Hiragino Sans"/>
-              </a:defRPr>
-            </a:pPr>
-            <a:r>
-              <a:t>権限設定</a:t>
-            </a:r>
-          </a:p>
-        </p:txBody>
-      </p:sp>
-      <p:sp>
-        <p:nvSpPr>
-          <p:cNvPr id="9" name="TextBox 8"/>
-          <p:cNvSpPr txBox="1"/>
-          <p:nvPr/>
-        </p:nvSpPr>
-        <p:spPr>
-          <a:xfrm>
-            <a:off x="6400800" y="3108960"/>
-            <a:ext cx="4572000" cy="731520"/>
-          </a:xfrm>
-          <a:prstGeom prst="rect">
-            <a:avLst/>
-          </a:prstGeom>
-          <a:noFill/>
-        </p:spPr>
-        <p:txBody>
-          <a:bodyPr wrap="square">
-            <a:spAutoFit/>
-          </a:bodyPr>
-          <a:lstStyle/>
-          <a:p>
-            <a:pPr algn="l">
-              <a:lnSpc>
-                <a:spcPts val="2250"/>
-              </a:lnSpc>
-              <a:spcAft>
-                <a:spcPts val="0"/>
-              </a:spcAft>
-              <a:defRPr sz="1500" b="0">
-                <a:solidFill>
-                  <a:srgbClr val="C5C3BB"/>
-                </a:solidFill>
-                <a:latin typeface="Hiragino Sans"/>
-              </a:defRPr>
-            </a:pPr>
-            <a:r>
-              <a:t>/config で確認・変更</a:t>
-            </a:r>
-            <a:br/>
-            <a:r>
-              <a:t>最初は Plan Mode 固定がおすすめ</a:t>
-            </a:r>
-          </a:p>
-        </p:txBody>
-      </p:sp>
-      <p:sp>
-        <p:nvSpPr>
-          <p:cNvPr id="10" name="TextBox 9"/>
-          <p:cNvSpPr txBox="1"/>
-          <p:nvPr/>
-        </p:nvSpPr>
-        <p:spPr>
-          <a:xfrm>
-            <a:off x="731520" y="3931920"/>
-            <a:ext cx="10058400" cy="457200"/>
-          </a:xfrm>
-          <a:prstGeom prst="rect">
-            <a:avLst/>
-          </a:prstGeom>
-          <a:noFill/>
-        </p:spPr>
-        <p:txBody>
-          <a:bodyPr wrap="square">
-            <a:spAutoFit/>
-          </a:bodyPr>
-          <a:lstStyle/>
-          <a:p>
-            <a:pPr algn="l">
-              <a:lnSpc>
-                <a:spcPts val="3000"/>
-              </a:lnSpc>
-              <a:spcAft>
-                <a:spcPts val="0"/>
-              </a:spcAft>
-              <a:defRPr sz="2000" b="1">
-                <a:solidFill>
-                  <a:srgbClr val="D97757"/>
-                </a:solidFill>
-                <a:latin typeface="Hiragino Sans"/>
-              </a:defRPr>
-            </a:pPr>
-            <a:r>
-              <a:t>最初のタスク例</a:t>
-            </a:r>
-          </a:p>
-        </p:txBody>
-      </p:sp>
-      <p:sp>
-        <p:nvSpPr>
-          <p:cNvPr id="11" name="Rounded Rectangle 10"/>
-          <p:cNvSpPr/>
-          <p:nvPr/>
-        </p:nvSpPr>
-        <p:spPr>
-          <a:xfrm>
-            <a:off x="731520" y="4480560"/>
-            <a:ext cx="10515600" cy="640080"/>
+            <a:off x="731520" y="1463040"/>
+            <a:ext cx="10515600" cy="1097280"/>
           </a:xfrm>
           <a:prstGeom prst="roundRect">
             <a:avLst>
@@ -9897,14 +9385,14 @@
       </p:sp>
       <p:sp>
         <p:nvSpPr>
-          <p:cNvPr id="12" name="TextBox 11"/>
-          <p:cNvSpPr txBox="1"/>
-          <p:nvPr/>
-        </p:nvSpPr>
-        <p:spPr>
-          <a:xfrm>
-            <a:off x="1188720" y="4590288"/>
-            <a:ext cx="9601200" cy="457200"/>
+          <p:cNvPr id="4" name="TextBox 3"/>
+          <p:cNvSpPr txBox="1"/>
+          <p:nvPr/>
+        </p:nvSpPr>
+        <p:spPr>
+          <a:xfrm>
+            <a:off x="1097280" y="1554480"/>
+            <a:ext cx="457200" cy="457200"/>
           </a:xfrm>
           <a:prstGeom prst="rect">
             <a:avLst/>
@@ -9919,34 +9407,122 @@
           <a:p>
             <a:pPr algn="l">
               <a:lnSpc>
-                <a:spcPts val="2400"/>
-              </a:lnSpc>
-              <a:spcAft>
-                <a:spcPts val="0"/>
-              </a:spcAft>
-              <a:defRPr sz="1600" b="0">
-                <a:solidFill>
-                  <a:srgbClr val="6A9BCC"/>
-                </a:solidFill>
-                <a:latin typeface="SF Mono"/>
-              </a:defRPr>
-            </a:pPr>
-            <a:r>
-              <a:t>「このリポジトリの構成を要約して」</a:t>
-            </a:r>
-          </a:p>
-        </p:txBody>
-      </p:sp>
-      <p:sp>
-        <p:nvSpPr>
-          <p:cNvPr id="13" name="Rounded Rectangle 12"/>
+                <a:spcPts val="4200"/>
+              </a:lnSpc>
+              <a:spcAft>
+                <a:spcPts val="0"/>
+              </a:spcAft>
+              <a:defRPr sz="2800" b="1">
+                <a:solidFill>
+                  <a:srgbClr val="D97757"/>
+                </a:solidFill>
+                <a:latin typeface="Helvetica Neue"/>
+              </a:defRPr>
+            </a:pPr>
+            <a:r>
+              <a:t>1</a:t>
+            </a:r>
+          </a:p>
+        </p:txBody>
+      </p:sp>
+      <p:sp>
+        <p:nvSpPr>
+          <p:cNvPr id="5" name="TextBox 4"/>
+          <p:cNvSpPr txBox="1"/>
+          <p:nvPr/>
+        </p:nvSpPr>
+        <p:spPr>
+          <a:xfrm>
+            <a:off x="1828800" y="1554480"/>
+            <a:ext cx="8686800" cy="457200"/>
+          </a:xfrm>
+          <a:prstGeom prst="rect">
+            <a:avLst/>
+          </a:prstGeom>
+          <a:noFill/>
+        </p:spPr>
+        <p:txBody>
+          <a:bodyPr wrap="square">
+            <a:spAutoFit/>
+          </a:bodyPr>
+          <a:lstStyle/>
+          <a:p>
+            <a:pPr algn="l">
+              <a:lnSpc>
+                <a:spcPts val="3000"/>
+              </a:lnSpc>
+              <a:spcAft>
+                <a:spcPts val="0"/>
+              </a:spcAft>
+              <a:defRPr sz="2000" b="1">
+                <a:solidFill>
+                  <a:srgbClr val="FAF9F5"/>
+                </a:solidFill>
+                <a:latin typeface="Hiragino Sans"/>
+              </a:defRPr>
+            </a:pPr>
+            <a:r>
+              <a:t>Claude Code はコード補完ではなく</a:t>
+            </a:r>
+            <a:br/>
+            <a:r>
+              <a:t>「作業を進める」ツール</a:t>
+            </a:r>
+          </a:p>
+        </p:txBody>
+      </p:sp>
+      <p:sp>
+        <p:nvSpPr>
+          <p:cNvPr id="6" name="TextBox 5"/>
+          <p:cNvSpPr txBox="1"/>
+          <p:nvPr/>
+        </p:nvSpPr>
+        <p:spPr>
+          <a:xfrm>
+            <a:off x="1828800" y="2057400"/>
+            <a:ext cx="8686800" cy="457200"/>
+          </a:xfrm>
+          <a:prstGeom prst="rect">
+            <a:avLst/>
+          </a:prstGeom>
+          <a:noFill/>
+        </p:spPr>
+        <p:txBody>
+          <a:bodyPr wrap="square">
+            <a:spAutoFit/>
+          </a:bodyPr>
+          <a:lstStyle/>
+          <a:p>
+            <a:pPr algn="l">
+              <a:lnSpc>
+                <a:spcPts val="2250"/>
+              </a:lnSpc>
+              <a:spcAft>
+                <a:spcPts val="0"/>
+              </a:spcAft>
+              <a:defRPr sz="1500" b="0">
+                <a:solidFill>
+                  <a:srgbClr val="C5C3BB"/>
+                </a:solidFill>
+                <a:latin typeface="Hiragino Sans"/>
+              </a:defRPr>
+            </a:pPr>
+            <a:r>
+              <a:t>調査→計画→実装→検証→取りまとめの一連フロー</a:t>
+            </a:r>
+          </a:p>
+        </p:txBody>
+      </p:sp>
+      <p:sp>
+        <p:nvSpPr>
+          <p:cNvPr id="7" name="Rounded Rectangle 6"/>
           <p:cNvSpPr/>
           <p:nvPr/>
         </p:nvSpPr>
         <p:spPr>
           <a:xfrm>
-            <a:off x="731520" y="5212080"/>
-            <a:ext cx="10515600" cy="640080"/>
+            <a:off x="731520" y="2743200"/>
+            <a:ext cx="10515600" cy="1097280"/>
           </a:xfrm>
           <a:prstGeom prst="roundRect">
             <a:avLst>
@@ -9984,14 +9560,14 @@
       </p:sp>
       <p:sp>
         <p:nvSpPr>
-          <p:cNvPr id="14" name="TextBox 13"/>
-          <p:cNvSpPr txBox="1"/>
-          <p:nvPr/>
-        </p:nvSpPr>
-        <p:spPr>
-          <a:xfrm>
-            <a:off x="1188720" y="5321808"/>
-            <a:ext cx="9601200" cy="457200"/>
+          <p:cNvPr id="8" name="TextBox 7"/>
+          <p:cNvSpPr txBox="1"/>
+          <p:nvPr/>
+        </p:nvSpPr>
+        <p:spPr>
+          <a:xfrm>
+            <a:off x="1097280" y="2834640"/>
+            <a:ext cx="457200" cy="457200"/>
           </a:xfrm>
           <a:prstGeom prst="rect">
             <a:avLst/>
@@ -10006,34 +9582,118 @@
           <a:p>
             <a:pPr algn="l">
               <a:lnSpc>
-                <a:spcPts val="2400"/>
-              </a:lnSpc>
-              <a:spcAft>
-                <a:spcPts val="0"/>
-              </a:spcAft>
-              <a:defRPr sz="1600" b="0">
-                <a:solidFill>
-                  <a:srgbClr val="6A9BCC"/>
-                </a:solidFill>
-                <a:latin typeface="SF Mono"/>
-              </a:defRPr>
-            </a:pPr>
-            <a:r>
-              <a:t>「テストを実行して、失敗しているケースがあれば原因を教えて」</a:t>
-            </a:r>
-          </a:p>
-        </p:txBody>
-      </p:sp>
-      <p:sp>
-        <p:nvSpPr>
-          <p:cNvPr id="15" name="Rounded Rectangle 14"/>
+                <a:spcPts val="4200"/>
+              </a:lnSpc>
+              <a:spcAft>
+                <a:spcPts val="0"/>
+              </a:spcAft>
+              <a:defRPr sz="2800" b="1">
+                <a:solidFill>
+                  <a:srgbClr val="D97757"/>
+                </a:solidFill>
+                <a:latin typeface="Helvetica Neue"/>
+              </a:defRPr>
+            </a:pPr>
+            <a:r>
+              <a:t>2</a:t>
+            </a:r>
+          </a:p>
+        </p:txBody>
+      </p:sp>
+      <p:sp>
+        <p:nvSpPr>
+          <p:cNvPr id="9" name="TextBox 8"/>
+          <p:cNvSpPr txBox="1"/>
+          <p:nvPr/>
+        </p:nvSpPr>
+        <p:spPr>
+          <a:xfrm>
+            <a:off x="1828800" y="2834640"/>
+            <a:ext cx="8686800" cy="457200"/>
+          </a:xfrm>
+          <a:prstGeom prst="rect">
+            <a:avLst/>
+          </a:prstGeom>
+          <a:noFill/>
+        </p:spPr>
+        <p:txBody>
+          <a:bodyPr wrap="square">
+            <a:spAutoFit/>
+          </a:bodyPr>
+          <a:lstStyle/>
+          <a:p>
+            <a:pPr algn="l">
+              <a:lnSpc>
+                <a:spcPts val="3000"/>
+              </a:lnSpc>
+              <a:spcAft>
+                <a:spcPts val="0"/>
+              </a:spcAft>
+              <a:defRPr sz="2000" b="1">
+                <a:solidFill>
+                  <a:srgbClr val="FAF9F5"/>
+                </a:solidFill>
+                <a:latin typeface="Hiragino Sans"/>
+              </a:defRPr>
+            </a:pPr>
+            <a:r>
+              <a:t>伝え方で結果が変わる</a:t>
+            </a:r>
+          </a:p>
+        </p:txBody>
+      </p:sp>
+      <p:sp>
+        <p:nvSpPr>
+          <p:cNvPr id="10" name="TextBox 9"/>
+          <p:cNvSpPr txBox="1"/>
+          <p:nvPr/>
+        </p:nvSpPr>
+        <p:spPr>
+          <a:xfrm>
+            <a:off x="1828800" y="3337560"/>
+            <a:ext cx="8686800" cy="457200"/>
+          </a:xfrm>
+          <a:prstGeom prst="rect">
+            <a:avLst/>
+          </a:prstGeom>
+          <a:noFill/>
+        </p:spPr>
+        <p:txBody>
+          <a:bodyPr wrap="square">
+            <a:spAutoFit/>
+          </a:bodyPr>
+          <a:lstStyle/>
+          <a:p>
+            <a:pPr algn="l">
+              <a:lnSpc>
+                <a:spcPts val="2250"/>
+              </a:lnSpc>
+              <a:spcAft>
+                <a:spcPts val="0"/>
+              </a:spcAft>
+              <a:defRPr sz="1500" b="0">
+                <a:solidFill>
+                  <a:srgbClr val="C5C3BB"/>
+                </a:solidFill>
+                <a:latin typeface="Hiragino Sans"/>
+              </a:defRPr>
+            </a:pPr>
+            <a:r>
+              <a:t>目標・背景・現状・期待出力を伝え、たたき台→改善ループで進める</a:t>
+            </a:r>
+          </a:p>
+        </p:txBody>
+      </p:sp>
+      <p:sp>
+        <p:nvSpPr>
+          <p:cNvPr id="11" name="Rounded Rectangle 10"/>
           <p:cNvSpPr/>
           <p:nvPr/>
         </p:nvSpPr>
         <p:spPr>
           <a:xfrm>
-            <a:off x="731520" y="5943600"/>
-            <a:ext cx="10515600" cy="640080"/>
+            <a:off x="731520" y="4023360"/>
+            <a:ext cx="10515600" cy="1097280"/>
           </a:xfrm>
           <a:prstGeom prst="roundRect">
             <a:avLst>
@@ -10071,49 +9731,175 @@
       </p:sp>
       <p:sp>
         <p:nvSpPr>
+          <p:cNvPr id="12" name="TextBox 11"/>
+          <p:cNvSpPr txBox="1"/>
+          <p:nvPr/>
+        </p:nvSpPr>
+        <p:spPr>
+          <a:xfrm>
+            <a:off x="1097280" y="4114800"/>
+            <a:ext cx="457200" cy="457200"/>
+          </a:xfrm>
+          <a:prstGeom prst="rect">
+            <a:avLst/>
+          </a:prstGeom>
+          <a:noFill/>
+        </p:spPr>
+        <p:txBody>
+          <a:bodyPr wrap="square">
+            <a:spAutoFit/>
+          </a:bodyPr>
+          <a:lstStyle/>
+          <a:p>
+            <a:pPr algn="l">
+              <a:lnSpc>
+                <a:spcPts val="4200"/>
+              </a:lnSpc>
+              <a:spcAft>
+                <a:spcPts val="0"/>
+              </a:spcAft>
+              <a:defRPr sz="2800" b="1">
+                <a:solidFill>
+                  <a:srgbClr val="D97757"/>
+                </a:solidFill>
+                <a:latin typeface="Helvetica Neue"/>
+              </a:defRPr>
+            </a:pPr>
+            <a:r>
+              <a:t>3</a:t>
+            </a:r>
+          </a:p>
+        </p:txBody>
+      </p:sp>
+      <p:sp>
+        <p:nvSpPr>
+          <p:cNvPr id="13" name="TextBox 12"/>
+          <p:cNvSpPr txBox="1"/>
+          <p:nvPr/>
+        </p:nvSpPr>
+        <p:spPr>
+          <a:xfrm>
+            <a:off x="1828800" y="4114800"/>
+            <a:ext cx="8686800" cy="457200"/>
+          </a:xfrm>
+          <a:prstGeom prst="rect">
+            <a:avLst/>
+          </a:prstGeom>
+          <a:noFill/>
+        </p:spPr>
+        <p:txBody>
+          <a:bodyPr wrap="square">
+            <a:spAutoFit/>
+          </a:bodyPr>
+          <a:lstStyle/>
+          <a:p>
+            <a:pPr algn="l">
+              <a:lnSpc>
+                <a:spcPts val="3000"/>
+              </a:lnSpc>
+              <a:spcAft>
+                <a:spcPts val="0"/>
+              </a:spcAft>
+              <a:defRPr sz="2000" b="1">
+                <a:solidFill>
+                  <a:srgbClr val="FAF9F5"/>
+                </a:solidFill>
+                <a:latin typeface="Hiragino Sans"/>
+              </a:defRPr>
+            </a:pPr>
+            <a:r>
+              <a:t>いきなりコードを書かせない</a:t>
+            </a:r>
+          </a:p>
+        </p:txBody>
+      </p:sp>
+      <p:sp>
+        <p:nvSpPr>
+          <p:cNvPr id="14" name="TextBox 13"/>
+          <p:cNvSpPr txBox="1"/>
+          <p:nvPr/>
+        </p:nvSpPr>
+        <p:spPr>
+          <a:xfrm>
+            <a:off x="1828800" y="4617720"/>
+            <a:ext cx="8686800" cy="457200"/>
+          </a:xfrm>
+          <a:prstGeom prst="rect">
+            <a:avLst/>
+          </a:prstGeom>
+          <a:noFill/>
+        </p:spPr>
+        <p:txBody>
+          <a:bodyPr wrap="square">
+            <a:spAutoFit/>
+          </a:bodyPr>
+          <a:lstStyle/>
+          <a:p>
+            <a:pPr algn="l">
+              <a:lnSpc>
+                <a:spcPts val="2250"/>
+              </a:lnSpc>
+              <a:spcAft>
+                <a:spcPts val="0"/>
+              </a:spcAft>
+              <a:defRPr sz="1500" b="0">
+                <a:solidFill>
+                  <a:srgbClr val="C5C3BB"/>
+                </a:solidFill>
+                <a:latin typeface="Hiragino Sans"/>
+              </a:defRPr>
+            </a:pPr>
+            <a:r>
+              <a:t>Plan Modeで方針を固めてから実装に入る</a:t>
+            </a:r>
+          </a:p>
+        </p:txBody>
+      </p:sp>
+      <p:sp>
+        <p:nvSpPr>
+          <p:cNvPr id="15" name="TextBox 14"/>
+          <p:cNvSpPr txBox="1"/>
+          <p:nvPr/>
+        </p:nvSpPr>
+        <p:spPr>
+          <a:xfrm>
+            <a:off x="731520" y="5486400"/>
+            <a:ext cx="10515600" cy="457200"/>
+          </a:xfrm>
+          <a:prstGeom prst="rect">
+            <a:avLst/>
+          </a:prstGeom>
+          <a:noFill/>
+        </p:spPr>
+        <p:txBody>
+          <a:bodyPr wrap="square">
+            <a:spAutoFit/>
+          </a:bodyPr>
+          <a:lstStyle/>
+          <a:p>
+            <a:pPr algn="l">
+              <a:lnSpc>
+                <a:spcPts val="2700"/>
+              </a:lnSpc>
+              <a:spcAft>
+                <a:spcPts val="0"/>
+              </a:spcAft>
+              <a:defRPr sz="1800" b="1">
+                <a:solidFill>
+                  <a:srgbClr val="D97757"/>
+                </a:solidFill>
+                <a:latin typeface="Hiragino Sans"/>
+              </a:defRPr>
+            </a:pPr>
+            <a:r>
+              <a:t>日常業務の一部を、Claude Codeに任せてみてください</a:t>
+            </a:r>
+          </a:p>
+        </p:txBody>
+      </p:sp>
+      <p:sp>
+        <p:nvSpPr>
           <p:cNvPr id="16" name="TextBox 15"/>
-          <p:cNvSpPr txBox="1"/>
-          <p:nvPr/>
-        </p:nvSpPr>
-        <p:spPr>
-          <a:xfrm>
-            <a:off x="1188720" y="6053328"/>
-            <a:ext cx="9601200" cy="457200"/>
-          </a:xfrm>
-          <a:prstGeom prst="rect">
-            <a:avLst/>
-          </a:prstGeom>
-          <a:noFill/>
-        </p:spPr>
-        <p:txBody>
-          <a:bodyPr wrap="square">
-            <a:spAutoFit/>
-          </a:bodyPr>
-          <a:lstStyle/>
-          <a:p>
-            <a:pPr algn="l">
-              <a:lnSpc>
-                <a:spcPts val="2400"/>
-              </a:lnSpc>
-              <a:spcAft>
-                <a:spcPts val="0"/>
-              </a:spcAft>
-              <a:defRPr sz="1600" b="0">
-                <a:solidFill>
-                  <a:srgbClr val="6A9BCC"/>
-                </a:solidFill>
-                <a:latin typeface="SF Mono"/>
-              </a:defRPr>
-            </a:pPr>
-            <a:r>
-              <a:t>「この関数の参照箇所を全部列挙して」</a:t>
-            </a:r>
-          </a:p>
-        </p:txBody>
-      </p:sp>
-      <p:sp>
-        <p:nvSpPr>
-          <p:cNvPr id="17" name="TextBox 16"/>
           <p:cNvSpPr txBox="1"/>
           <p:nvPr/>
         </p:nvSpPr>
@@ -10148,676 +9934,7 @@
               </a:defRPr>
             </a:pPr>
             <a:r>
-              <a:t>15 / 16</a:t>
-            </a:r>
-          </a:p>
-        </p:txBody>
-      </p:sp>
-    </p:spTree>
-  </p:cSld>
-  <p:clrMapOvr>
-    <a:masterClrMapping/>
-  </p:clrMapOvr>
-</p:sld>
-</file>
-
-<file path=ppt/slides/slide16.xml><?xml version="1.0" encoding="utf-8"?>
-<p:sld xmlns:a="http://schemas.openxmlformats.org/drawingml/2006/main" xmlns:p="http://schemas.openxmlformats.org/presentationml/2006/main" xmlns:r="http://schemas.openxmlformats.org/officeDocument/2006/relationships">
-  <p:cSld>
-    <p:bg>
-      <p:bgPr>
-        <a:solidFill>
-          <a:srgbClr val="1B1918"/>
-        </a:solidFill>
-        <a:effectLst/>
-      </p:bgPr>
-    </p:bg>
-    <p:spTree>
-      <p:nvGrpSpPr>
-        <p:cNvPr id="1" name=""/>
-        <p:cNvGrpSpPr/>
-        <p:nvPr/>
-      </p:nvGrpSpPr>
-      <p:grpSpPr/>
-      <p:sp>
-        <p:nvSpPr>
-          <p:cNvPr id="2" name="TextBox 1"/>
-          <p:cNvSpPr txBox="1"/>
-          <p:nvPr/>
-        </p:nvSpPr>
-        <p:spPr>
-          <a:xfrm>
-            <a:off x="731520" y="457200"/>
-            <a:ext cx="10058400" cy="731520"/>
-          </a:xfrm>
-          <a:prstGeom prst="rect">
-            <a:avLst/>
-          </a:prstGeom>
-          <a:noFill/>
-        </p:spPr>
-        <p:txBody>
-          <a:bodyPr wrap="square">
-            <a:spAutoFit/>
-          </a:bodyPr>
-          <a:lstStyle/>
-          <a:p>
-            <a:pPr algn="l">
-              <a:lnSpc>
-                <a:spcPts val="5400"/>
-              </a:lnSpc>
-              <a:spcAft>
-                <a:spcPts val="0"/>
-              </a:spcAft>
-              <a:defRPr sz="3600" b="1">
-                <a:solidFill>
-                  <a:srgbClr val="FAF9F5"/>
-                </a:solidFill>
-                <a:latin typeface="Hiragino Sans"/>
-              </a:defRPr>
-            </a:pPr>
-            <a:r>
-              <a:t>まとめ / 次回予告</a:t>
-            </a:r>
-          </a:p>
-        </p:txBody>
-      </p:sp>
-      <p:sp>
-        <p:nvSpPr>
-          <p:cNvPr id="3" name="Rounded Rectangle 2"/>
-          <p:cNvSpPr/>
-          <p:nvPr/>
-        </p:nvSpPr>
-        <p:spPr>
-          <a:xfrm>
-            <a:off x="731520" y="1463040"/>
-            <a:ext cx="10515600" cy="1097280"/>
-          </a:xfrm>
-          <a:prstGeom prst="roundRect">
-            <a:avLst>
-              <a:gd name="adj" fmla="val 2000"/>
-            </a:avLst>
-          </a:prstGeom>
-          <a:solidFill>
-            <a:srgbClr val="252220"/>
-          </a:solidFill>
-          <a:ln>
-            <a:noFill/>
-          </a:ln>
-        </p:spPr>
-        <p:style>
-          <a:lnRef idx="1">
-            <a:schemeClr val="accent1"/>
-          </a:lnRef>
-          <a:fillRef idx="3">
-            <a:schemeClr val="accent1"/>
-          </a:fillRef>
-          <a:effectRef idx="2">
-            <a:schemeClr val="accent1"/>
-          </a:effectRef>
-          <a:fontRef idx="minor">
-            <a:schemeClr val="lt1"/>
-          </a:fontRef>
-        </p:style>
-        <p:txBody>
-          <a:bodyPr rtlCol="0" anchor="ctr"/>
-          <a:lstStyle/>
-          <a:p>
-            <a:pPr algn="ctr"/>
-          </a:p>
-        </p:txBody>
-      </p:sp>
-      <p:sp>
-        <p:nvSpPr>
-          <p:cNvPr id="4" name="TextBox 3"/>
-          <p:cNvSpPr txBox="1"/>
-          <p:nvPr/>
-        </p:nvSpPr>
-        <p:spPr>
-          <a:xfrm>
-            <a:off x="1097280" y="1554480"/>
-            <a:ext cx="457200" cy="457200"/>
-          </a:xfrm>
-          <a:prstGeom prst="rect">
-            <a:avLst/>
-          </a:prstGeom>
-          <a:noFill/>
-        </p:spPr>
-        <p:txBody>
-          <a:bodyPr wrap="square">
-            <a:spAutoFit/>
-          </a:bodyPr>
-          <a:lstStyle/>
-          <a:p>
-            <a:pPr algn="l">
-              <a:lnSpc>
-                <a:spcPts val="4200"/>
-              </a:lnSpc>
-              <a:spcAft>
-                <a:spcPts val="0"/>
-              </a:spcAft>
-              <a:defRPr sz="2800" b="1">
-                <a:solidFill>
-                  <a:srgbClr val="D97757"/>
-                </a:solidFill>
-                <a:latin typeface="Helvetica Neue"/>
-              </a:defRPr>
-            </a:pPr>
-            <a:r>
-              <a:t>1</a:t>
-            </a:r>
-          </a:p>
-        </p:txBody>
-      </p:sp>
-      <p:sp>
-        <p:nvSpPr>
-          <p:cNvPr id="5" name="TextBox 4"/>
-          <p:cNvSpPr txBox="1"/>
-          <p:nvPr/>
-        </p:nvSpPr>
-        <p:spPr>
-          <a:xfrm>
-            <a:off x="1828800" y="1554480"/>
-            <a:ext cx="8686800" cy="457200"/>
-          </a:xfrm>
-          <a:prstGeom prst="rect">
-            <a:avLst/>
-          </a:prstGeom>
-          <a:noFill/>
-        </p:spPr>
-        <p:txBody>
-          <a:bodyPr wrap="square">
-            <a:spAutoFit/>
-          </a:bodyPr>
-          <a:lstStyle/>
-          <a:p>
-            <a:pPr algn="l">
-              <a:lnSpc>
-                <a:spcPts val="3000"/>
-              </a:lnSpc>
-              <a:spcAft>
-                <a:spcPts val="0"/>
-              </a:spcAft>
-              <a:defRPr sz="2000" b="1">
-                <a:solidFill>
-                  <a:srgbClr val="FAF9F5"/>
-                </a:solidFill>
-                <a:latin typeface="Hiragino Sans"/>
-              </a:defRPr>
-            </a:pPr>
-            <a:r>
-              <a:t>Claude Code はコード補完ではなく</a:t>
-            </a:r>
-            <a:br/>
-            <a:r>
-              <a:t>「作業を進める」ツール</a:t>
-            </a:r>
-          </a:p>
-        </p:txBody>
-      </p:sp>
-      <p:sp>
-        <p:nvSpPr>
-          <p:cNvPr id="6" name="TextBox 5"/>
-          <p:cNvSpPr txBox="1"/>
-          <p:nvPr/>
-        </p:nvSpPr>
-        <p:spPr>
-          <a:xfrm>
-            <a:off x="1828800" y="2057400"/>
-            <a:ext cx="8686800" cy="457200"/>
-          </a:xfrm>
-          <a:prstGeom prst="rect">
-            <a:avLst/>
-          </a:prstGeom>
-          <a:noFill/>
-        </p:spPr>
-        <p:txBody>
-          <a:bodyPr wrap="square">
-            <a:spAutoFit/>
-          </a:bodyPr>
-          <a:lstStyle/>
-          <a:p>
-            <a:pPr algn="l">
-              <a:lnSpc>
-                <a:spcPts val="2250"/>
-              </a:lnSpc>
-              <a:spcAft>
-                <a:spcPts val="0"/>
-              </a:spcAft>
-              <a:defRPr sz="1500" b="0">
-                <a:solidFill>
-                  <a:srgbClr val="C5C3BB"/>
-                </a:solidFill>
-                <a:latin typeface="Hiragino Sans"/>
-              </a:defRPr>
-            </a:pPr>
-            <a:r>
-              <a:t>調査→計画→実装→検証→取りまとめの一連フロー</a:t>
-            </a:r>
-          </a:p>
-        </p:txBody>
-      </p:sp>
-      <p:sp>
-        <p:nvSpPr>
-          <p:cNvPr id="7" name="Rounded Rectangle 6"/>
-          <p:cNvSpPr/>
-          <p:nvPr/>
-        </p:nvSpPr>
-        <p:spPr>
-          <a:xfrm>
-            <a:off x="731520" y="2743200"/>
-            <a:ext cx="10515600" cy="1097280"/>
-          </a:xfrm>
-          <a:prstGeom prst="roundRect">
-            <a:avLst>
-              <a:gd name="adj" fmla="val 2000"/>
-            </a:avLst>
-          </a:prstGeom>
-          <a:solidFill>
-            <a:srgbClr val="252220"/>
-          </a:solidFill>
-          <a:ln>
-            <a:noFill/>
-          </a:ln>
-        </p:spPr>
-        <p:style>
-          <a:lnRef idx="1">
-            <a:schemeClr val="accent1"/>
-          </a:lnRef>
-          <a:fillRef idx="3">
-            <a:schemeClr val="accent1"/>
-          </a:fillRef>
-          <a:effectRef idx="2">
-            <a:schemeClr val="accent1"/>
-          </a:effectRef>
-          <a:fontRef idx="minor">
-            <a:schemeClr val="lt1"/>
-          </a:fontRef>
-        </p:style>
-        <p:txBody>
-          <a:bodyPr rtlCol="0" anchor="ctr"/>
-          <a:lstStyle/>
-          <a:p>
-            <a:pPr algn="ctr"/>
-          </a:p>
-        </p:txBody>
-      </p:sp>
-      <p:sp>
-        <p:nvSpPr>
-          <p:cNvPr id="8" name="TextBox 7"/>
-          <p:cNvSpPr txBox="1"/>
-          <p:nvPr/>
-        </p:nvSpPr>
-        <p:spPr>
-          <a:xfrm>
-            <a:off x="1097280" y="2834640"/>
-            <a:ext cx="457200" cy="457200"/>
-          </a:xfrm>
-          <a:prstGeom prst="rect">
-            <a:avLst/>
-          </a:prstGeom>
-          <a:noFill/>
-        </p:spPr>
-        <p:txBody>
-          <a:bodyPr wrap="square">
-            <a:spAutoFit/>
-          </a:bodyPr>
-          <a:lstStyle/>
-          <a:p>
-            <a:pPr algn="l">
-              <a:lnSpc>
-                <a:spcPts val="4200"/>
-              </a:lnSpc>
-              <a:spcAft>
-                <a:spcPts val="0"/>
-              </a:spcAft>
-              <a:defRPr sz="2800" b="1">
-                <a:solidFill>
-                  <a:srgbClr val="D97757"/>
-                </a:solidFill>
-                <a:latin typeface="Helvetica Neue"/>
-              </a:defRPr>
-            </a:pPr>
-            <a:r>
-              <a:t>2</a:t>
-            </a:r>
-          </a:p>
-        </p:txBody>
-      </p:sp>
-      <p:sp>
-        <p:nvSpPr>
-          <p:cNvPr id="9" name="TextBox 8"/>
-          <p:cNvSpPr txBox="1"/>
-          <p:nvPr/>
-        </p:nvSpPr>
-        <p:spPr>
-          <a:xfrm>
-            <a:off x="1828800" y="2834640"/>
-            <a:ext cx="8686800" cy="457200"/>
-          </a:xfrm>
-          <a:prstGeom prst="rect">
-            <a:avLst/>
-          </a:prstGeom>
-          <a:noFill/>
-        </p:spPr>
-        <p:txBody>
-          <a:bodyPr wrap="square">
-            <a:spAutoFit/>
-          </a:bodyPr>
-          <a:lstStyle/>
-          <a:p>
-            <a:pPr algn="l">
-              <a:lnSpc>
-                <a:spcPts val="3000"/>
-              </a:lnSpc>
-              <a:spcAft>
-                <a:spcPts val="0"/>
-              </a:spcAft>
-              <a:defRPr sz="2000" b="1">
-                <a:solidFill>
-                  <a:srgbClr val="FAF9F5"/>
-                </a:solidFill>
-                <a:latin typeface="Hiragino Sans"/>
-              </a:defRPr>
-            </a:pPr>
-            <a:r>
-              <a:t>伝え方で結果が変わる</a:t>
-            </a:r>
-          </a:p>
-        </p:txBody>
-      </p:sp>
-      <p:sp>
-        <p:nvSpPr>
-          <p:cNvPr id="10" name="TextBox 9"/>
-          <p:cNvSpPr txBox="1"/>
-          <p:nvPr/>
-        </p:nvSpPr>
-        <p:spPr>
-          <a:xfrm>
-            <a:off x="1828800" y="3337560"/>
-            <a:ext cx="8686800" cy="457200"/>
-          </a:xfrm>
-          <a:prstGeom prst="rect">
-            <a:avLst/>
-          </a:prstGeom>
-          <a:noFill/>
-        </p:spPr>
-        <p:txBody>
-          <a:bodyPr wrap="square">
-            <a:spAutoFit/>
-          </a:bodyPr>
-          <a:lstStyle/>
-          <a:p>
-            <a:pPr algn="l">
-              <a:lnSpc>
-                <a:spcPts val="2250"/>
-              </a:lnSpc>
-              <a:spcAft>
-                <a:spcPts val="0"/>
-              </a:spcAft>
-              <a:defRPr sz="1500" b="0">
-                <a:solidFill>
-                  <a:srgbClr val="C5C3BB"/>
-                </a:solidFill>
-                <a:latin typeface="Hiragino Sans"/>
-              </a:defRPr>
-            </a:pPr>
-            <a:r>
-              <a:t>目標・背景・現状・期待出力を伝え、たたき台→改善ループで進める</a:t>
-            </a:r>
-          </a:p>
-        </p:txBody>
-      </p:sp>
-      <p:sp>
-        <p:nvSpPr>
-          <p:cNvPr id="11" name="Rounded Rectangle 10"/>
-          <p:cNvSpPr/>
-          <p:nvPr/>
-        </p:nvSpPr>
-        <p:spPr>
-          <a:xfrm>
-            <a:off x="731520" y="4023360"/>
-            <a:ext cx="10515600" cy="1097280"/>
-          </a:xfrm>
-          <a:prstGeom prst="roundRect">
-            <a:avLst>
-              <a:gd name="adj" fmla="val 2000"/>
-            </a:avLst>
-          </a:prstGeom>
-          <a:solidFill>
-            <a:srgbClr val="252220"/>
-          </a:solidFill>
-          <a:ln>
-            <a:noFill/>
-          </a:ln>
-        </p:spPr>
-        <p:style>
-          <a:lnRef idx="1">
-            <a:schemeClr val="accent1"/>
-          </a:lnRef>
-          <a:fillRef idx="3">
-            <a:schemeClr val="accent1"/>
-          </a:fillRef>
-          <a:effectRef idx="2">
-            <a:schemeClr val="accent1"/>
-          </a:effectRef>
-          <a:fontRef idx="minor">
-            <a:schemeClr val="lt1"/>
-          </a:fontRef>
-        </p:style>
-        <p:txBody>
-          <a:bodyPr rtlCol="0" anchor="ctr"/>
-          <a:lstStyle/>
-          <a:p>
-            <a:pPr algn="ctr"/>
-          </a:p>
-        </p:txBody>
-      </p:sp>
-      <p:sp>
-        <p:nvSpPr>
-          <p:cNvPr id="12" name="TextBox 11"/>
-          <p:cNvSpPr txBox="1"/>
-          <p:nvPr/>
-        </p:nvSpPr>
-        <p:spPr>
-          <a:xfrm>
-            <a:off x="1097280" y="4114800"/>
-            <a:ext cx="457200" cy="457200"/>
-          </a:xfrm>
-          <a:prstGeom prst="rect">
-            <a:avLst/>
-          </a:prstGeom>
-          <a:noFill/>
-        </p:spPr>
-        <p:txBody>
-          <a:bodyPr wrap="square">
-            <a:spAutoFit/>
-          </a:bodyPr>
-          <a:lstStyle/>
-          <a:p>
-            <a:pPr algn="l">
-              <a:lnSpc>
-                <a:spcPts val="4200"/>
-              </a:lnSpc>
-              <a:spcAft>
-                <a:spcPts val="0"/>
-              </a:spcAft>
-              <a:defRPr sz="2800" b="1">
-                <a:solidFill>
-                  <a:srgbClr val="D97757"/>
-                </a:solidFill>
-                <a:latin typeface="Helvetica Neue"/>
-              </a:defRPr>
-            </a:pPr>
-            <a:r>
-              <a:t>3</a:t>
-            </a:r>
-          </a:p>
-        </p:txBody>
-      </p:sp>
-      <p:sp>
-        <p:nvSpPr>
-          <p:cNvPr id="13" name="TextBox 12"/>
-          <p:cNvSpPr txBox="1"/>
-          <p:nvPr/>
-        </p:nvSpPr>
-        <p:spPr>
-          <a:xfrm>
-            <a:off x="1828800" y="4114800"/>
-            <a:ext cx="8686800" cy="457200"/>
-          </a:xfrm>
-          <a:prstGeom prst="rect">
-            <a:avLst/>
-          </a:prstGeom>
-          <a:noFill/>
-        </p:spPr>
-        <p:txBody>
-          <a:bodyPr wrap="square">
-            <a:spAutoFit/>
-          </a:bodyPr>
-          <a:lstStyle/>
-          <a:p>
-            <a:pPr algn="l">
-              <a:lnSpc>
-                <a:spcPts val="3000"/>
-              </a:lnSpc>
-              <a:spcAft>
-                <a:spcPts val="0"/>
-              </a:spcAft>
-              <a:defRPr sz="2000" b="1">
-                <a:solidFill>
-                  <a:srgbClr val="FAF9F5"/>
-                </a:solidFill>
-                <a:latin typeface="Hiragino Sans"/>
-              </a:defRPr>
-            </a:pPr>
-            <a:r>
-              <a:t>いきなりコードを書かせない</a:t>
-            </a:r>
-          </a:p>
-        </p:txBody>
-      </p:sp>
-      <p:sp>
-        <p:nvSpPr>
-          <p:cNvPr id="14" name="TextBox 13"/>
-          <p:cNvSpPr txBox="1"/>
-          <p:nvPr/>
-        </p:nvSpPr>
-        <p:spPr>
-          <a:xfrm>
-            <a:off x="1828800" y="4617720"/>
-            <a:ext cx="8686800" cy="457200"/>
-          </a:xfrm>
-          <a:prstGeom prst="rect">
-            <a:avLst/>
-          </a:prstGeom>
-          <a:noFill/>
-        </p:spPr>
-        <p:txBody>
-          <a:bodyPr wrap="square">
-            <a:spAutoFit/>
-          </a:bodyPr>
-          <a:lstStyle/>
-          <a:p>
-            <a:pPr algn="l">
-              <a:lnSpc>
-                <a:spcPts val="2250"/>
-              </a:lnSpc>
-              <a:spcAft>
-                <a:spcPts val="0"/>
-              </a:spcAft>
-              <a:defRPr sz="1500" b="0">
-                <a:solidFill>
-                  <a:srgbClr val="C5C3BB"/>
-                </a:solidFill>
-                <a:latin typeface="Hiragino Sans"/>
-              </a:defRPr>
-            </a:pPr>
-            <a:r>
-              <a:t>Plan Modeで方針を固めてから実装に入る</a:t>
-            </a:r>
-          </a:p>
-        </p:txBody>
-      </p:sp>
-      <p:sp>
-        <p:nvSpPr>
-          <p:cNvPr id="15" name="TextBox 14"/>
-          <p:cNvSpPr txBox="1"/>
-          <p:nvPr/>
-        </p:nvSpPr>
-        <p:spPr>
-          <a:xfrm>
-            <a:off x="731520" y="5486400"/>
-            <a:ext cx="10515600" cy="457200"/>
-          </a:xfrm>
-          <a:prstGeom prst="rect">
-            <a:avLst/>
-          </a:prstGeom>
-          <a:noFill/>
-        </p:spPr>
-        <p:txBody>
-          <a:bodyPr wrap="square">
-            <a:spAutoFit/>
-          </a:bodyPr>
-          <a:lstStyle/>
-          <a:p>
-            <a:pPr algn="l">
-              <a:lnSpc>
-                <a:spcPts val="2700"/>
-              </a:lnSpc>
-              <a:spcAft>
-                <a:spcPts val="0"/>
-              </a:spcAft>
-              <a:defRPr sz="1800" b="1">
-                <a:solidFill>
-                  <a:srgbClr val="D97757"/>
-                </a:solidFill>
-                <a:latin typeface="Hiragino Sans"/>
-              </a:defRPr>
-            </a:pPr>
-            <a:r>
-              <a:t>面倒な調査タスクを1件、Claude Codeに任せてみてください</a:t>
-            </a:r>
-          </a:p>
-        </p:txBody>
-      </p:sp>
-      <p:sp>
-        <p:nvSpPr>
-          <p:cNvPr id="16" name="TextBox 15"/>
-          <p:cNvSpPr txBox="1"/>
-          <p:nvPr/>
-        </p:nvSpPr>
-        <p:spPr>
-          <a:xfrm>
-            <a:off x="11277295" y="6400800"/>
-            <a:ext cx="731520" cy="274320"/>
-          </a:xfrm>
-          <a:prstGeom prst="rect">
-            <a:avLst/>
-          </a:prstGeom>
-          <a:noFill/>
-        </p:spPr>
-        <p:txBody>
-          <a:bodyPr wrap="square">
-            <a:spAutoFit/>
-          </a:bodyPr>
-          <a:lstStyle/>
-          <a:p>
-            <a:pPr algn="r">
-              <a:lnSpc>
-                <a:spcPts val="1500"/>
-              </a:lnSpc>
-              <a:spcAft>
-                <a:spcPts val="0"/>
-              </a:spcAft>
-              <a:defRPr sz="1000" b="0">
-                <a:solidFill>
-                  <a:srgbClr val="B0AEA5"/>
-                </a:solidFill>
-                <a:latin typeface="Helvetica Neue"/>
-              </a:defRPr>
-            </a:pPr>
-            <a:r>
-              <a:t>16 / 16</a:t>
+              <a:t>15 / 15</a:t>
             </a:r>
           </a:p>
         </p:txBody>
@@ -11185,7 +10302,11 @@
               </a:defRPr>
             </a:pPr>
             <a:r>
-              <a:t>カスタマイズする</a:t>
+              <a:t>プロジェクトに合わせた</a:t>
+            </a:r>
+            <a:br/>
+            <a:r>
+              <a:t>カスタマイズ</a:t>
             </a:r>
           </a:p>
         </p:txBody>
@@ -11227,7 +10348,7 @@
               </a:defRPr>
             </a:pPr>
             <a:r>
-              <a:t>コンテキスト管理 / Skills / サブエージェント</a:t>
+              <a:t>CLAUDE.md / Skills / Hooks</a:t>
             </a:r>
           </a:p>
         </p:txBody>
@@ -11356,7 +10477,7 @@
               </a:defRPr>
             </a:pPr>
             <a:r>
-              <a:t>スケールさせる</a:t>
+              <a:t>外部連携と並列開発</a:t>
             </a:r>
           </a:p>
         </p:txBody>
@@ -11398,7 +10519,7 @@
               </a:defRPr>
             </a:pPr>
             <a:r>
-              <a:t>Hooks / MCP / worktree / /insights</a:t>
+              <a:t>MCP / worktree / サブエージェント</a:t>
             </a:r>
           </a:p>
         </p:txBody>
@@ -11440,7 +10561,7 @@
               </a:defRPr>
             </a:pPr>
             <a:r>
-              <a:t>今日のゴール: 面倒な調査タスクを1件、Claude Codeに任せられるようになる</a:t>
+              <a:t>今日のゴール: 日常業務の一部をClaude Codeに任せられるようになる</a:t>
             </a:r>
           </a:p>
         </p:txBody>
@@ -11482,7 +10603,7 @@
               </a:defRPr>
             </a:pPr>
             <a:r>
-              <a:t>2 / 16</a:t>
+              <a:t>2 / 15</a:t>
             </a:r>
           </a:p>
         </p:txBody>
@@ -12034,7 +11155,7 @@
               </a:defRPr>
             </a:pPr>
             <a:r>
-              <a:t>3 / 16</a:t>
+              <a:t>3 / 15</a:t>
             </a:r>
           </a:p>
         </p:txBody>
@@ -12732,7 +11853,7 @@
               </a:defRPr>
             </a:pPr>
             <a:r>
-              <a:t>4 / 16</a:t>
+              <a:t>4 / 15</a:t>
             </a:r>
           </a:p>
         </p:txBody>
@@ -13439,7 +12560,7 @@
               </a:defRPr>
             </a:pPr>
             <a:r>
-              <a:t>5 / 16</a:t>
+              <a:t>5 / 15</a:t>
             </a:r>
           </a:p>
         </p:txBody>
@@ -15481,7 +14602,7 @@
               </a:defRPr>
             </a:pPr>
             <a:r>
-              <a:t>6 / 16</a:t>
+              <a:t>6 / 15</a:t>
             </a:r>
           </a:p>
         </p:txBody>
@@ -16444,7 +15565,7 @@
               </a:defRPr>
             </a:pPr>
             <a:r>
-              <a:t>7 / 16</a:t>
+              <a:t>7 / 15</a:t>
             </a:r>
           </a:p>
         </p:txBody>
@@ -16642,7 +15763,7 @@
               </a:defRPr>
             </a:pPr>
             <a:r>
-              <a:t>8 / 16</a:t>
+              <a:t>8 / 15</a:t>
             </a:r>
           </a:p>
         </p:txBody>
@@ -17266,7 +16387,7 @@
               </a:defRPr>
             </a:pPr>
             <a:r>
-              <a:t>9 / 16</a:t>
+              <a:t>9 / 15</a:t>
             </a:r>
           </a:p>
         </p:txBody>

</xml_diff>